<commit_message>
Add a Streamlit interface slide, with screenshot auto-fill
New slide 5 showcases the second UI. Its point is architectural rather
than cosmetic: the vocabulary, the search and the three-stage pipeline
live in hpo_vocab.py and annotate.py, neither of which knows about a UI,
so a second front end reuses them and inherits the same guarantee that
output can only be a phenotype.hpoa term.

Screenshots are now data rather than hand-placed objects. make_deck.py
reads deck-assets/<name>.png, fits it to its box preserving aspect
ratio, and falls back to a dashed placeholder naming the expected file
when it is absent, so the deck always builds. Verified both branches.

Two placeholders remain on the slide for the author: the screenshot
itself, and one line on why the Streamlit version exists.

The deck is now six slides; slide 4 should come down to ~1:40 to stay
inside five minutes including questions.

Co-Authored-By: Claude Opus 5 <noreply@anthropic.com>
</commit_message>
<xml_diff>
--- a/session-2/projects/hpo-scribe/hpo-scribe-presentation.pptx
+++ b/session-2/projects/hpo-scribe/hpo-scribe-presentation.pptx
@@ -10,6 +10,7 @@
     <p:sldId id="258" r:id="rId10"/>
     <p:sldId id="259" r:id="rId11"/>
     <p:sldId id="260" r:id="rId12"/>
+    <p:sldId id="261" r:id="rId13"/>
   </p:sldIdLst>
   <p:sldSz cx="12191695" cy="6858000" type="screen4x3"/>
   <p:notesSz cx="6858000" cy="9144000"/>
@@ -844,6 +845,124 @@
 </file>
 
 <file path=ppt/notesSlides/notesSlide5.xml><?xml version="1.0" encoding="utf-8"?>
+<p:notes xmlns:a="http://schemas.openxmlformats.org/drawingml/2006/main" xmlns:p="http://schemas.openxmlformats.org/presentationml/2006/main" xmlns:r="http://schemas.openxmlformats.org/officeDocument/2006/relationships">
+  <p:cSld>
+    <p:spTree>
+      <p:nvGrpSpPr>
+        <p:cNvPr id="1" name=""/>
+        <p:cNvGrpSpPr/>
+        <p:nvPr/>
+      </p:nvGrpSpPr>
+      <p:grpSpPr>
+        <a:xfrm>
+          <a:off x="0" y="0"/>
+          <a:ext cx="0" cy="0"/>
+          <a:chOff x="0" y="0"/>
+          <a:chExt cx="0" cy="0"/>
+        </a:xfrm>
+      </p:grpSpPr>
+      <p:sp>
+        <p:nvSpPr>
+          <p:cNvPr id="2" name="Slide Image Placeholder 1"/>
+          <p:cNvSpPr>
+            <a:spLocks noGrp="1"/>
+          </p:cNvSpPr>
+          <p:nvPr>
+            <p:ph type="sldImg" idx="2"/>
+          </p:nvPr>
+        </p:nvSpPr>
+        <p:spPr/>
+      </p:sp>
+      <p:sp>
+        <p:nvSpPr>
+          <p:cNvPr id="3" name="Notes Placeholder 2"/>
+          <p:cNvSpPr>
+            <a:spLocks noGrp="1"/>
+          </p:cNvSpPr>
+          <p:nvPr>
+            <p:ph type="body" idx="3" sz="quarter"/>
+          </p:nvPr>
+        </p:nvSpPr>
+        <p:spPr/>
+        <p:txBody>
+          <a:bodyPr/>
+          <a:lstStyle/>
+          <a:p>
+            <a:r>
+              <a:t>20 sec. This slide is a bonus, not a pillar - if you are running long, cut it and</a:t>
+            </a:r>
+          </a:p>
+          <a:p>
+            <a:r>
+              <a:t>mention the second UI in one sentence on slide 4 instead.</a:t>
+            </a:r>
+          </a:p>
+          <a:p/>
+          <a:p>
+            <a:r>
+              <a:t>The point worth making is architectural, not cosmetic: the constraint that output can</a:t>
+            </a:r>
+          </a:p>
+          <a:p>
+            <a:r>
+              <a:t>only be a phenotype.hpoa term lives in the library, so BOTH interfaces inherit it. A</a:t>
+            </a:r>
+          </a:p>
+          <a:p>
+            <a:r>
+              <a:t>UI cannot weaken it, and neither can a human using one - the correction dropdown only</a:t>
+            </a:r>
+          </a:p>
+          <a:p>
+            <a:r>
+              <a:t>offers retrieved candidates, and the save path re-validates.</a:t>
+            </a:r>
+          </a:p>
+          <a:p/>
+          <a:p>
+            <a:r>
+              <a:t>&gt;&gt;&gt; Replace the third bullet with the real reason the Streamlit version exists. &lt;&lt;&lt;</a:t>
+            </a:r>
+          </a:p>
+          <a:p>
+            <a:r>
+              <a:t>&gt;&gt;&gt; Drop the screenshot into deck-assets/streamlit-main.png and re-run make_deck.py. &lt;&lt;&lt;</a:t>
+            </a:r>
+          </a:p>
+          <a:p/>
+          <a:p>
+            <a:r>
+              <a:t>Adding this slide pushes the deck to six. Slide 4 should come down to about 1:40 to</a:t>
+            </a:r>
+          </a:p>
+          <a:p>
+            <a:r>
+              <a:t>keep the whole thing inside five minutes including questions.</a:t>
+            </a:r>
+          </a:p>
+        </p:txBody>
+      </p:sp>
+      <p:sp>
+        <p:nvSpPr>
+          <p:cNvPr id="4" name="Slide Number Placeholder 3"/>
+          <p:cNvSpPr>
+            <a:spLocks noGrp="1"/>
+          </p:cNvSpPr>
+          <p:nvPr>
+            <p:ph type="sldNum" idx="5" sz="quarter"/>
+          </p:nvPr>
+        </p:nvSpPr>
+        <p:spPr/>
+      </p:sp>
+    </p:spTree>
+  </p:cSld>
+  <p:clrMapOvr>
+    <a:masterClrMapping/>
+  </p:clrMapOvr>
+</p:notes>
+</file>
+
+<file path=ppt/notesSlides/notesSlide6.xml><?xml version="1.0" encoding="utf-8"?>
 <p:notes xmlns:a="http://schemas.openxmlformats.org/drawingml/2006/main" xmlns:p="http://schemas.openxmlformats.org/presentationml/2006/main" xmlns:r="http://schemas.openxmlformats.org/officeDocument/2006/relationships">
   <p:cSld>
     <p:spTree>
@@ -6550,6 +6669,460 @@
 </file>
 
 <file path=ppt/slides/slide5.xml><?xml version="1.0" encoding="utf-8"?>
+<p:sld xmlns:a="http://schemas.openxmlformats.org/drawingml/2006/main" xmlns:p="http://schemas.openxmlformats.org/presentationml/2006/main" xmlns:r="http://schemas.openxmlformats.org/officeDocument/2006/relationships">
+  <p:cSld>
+    <p:spTree>
+      <p:nvGrpSpPr>
+        <p:cNvPr id="1" name=""/>
+        <p:cNvGrpSpPr/>
+        <p:nvPr/>
+      </p:nvGrpSpPr>
+      <p:grpSpPr/>
+      <p:sp>
+        <p:nvSpPr>
+          <p:cNvPr id="2" name="TextBox 1"/>
+          <p:cNvSpPr txBox="1"/>
+          <p:nvPr/>
+        </p:nvSpPr>
+        <p:spPr>
+          <a:xfrm>
+            <a:off x="658368" y="457200"/>
+            <a:ext cx="8229600" cy="640080"/>
+          </a:xfrm>
+          <a:prstGeom prst="rect">
+            <a:avLst/>
+          </a:prstGeom>
+          <a:noFill/>
+        </p:spPr>
+        <p:txBody>
+          <a:bodyPr wrap="square" anchor="t" lIns="0" rIns="0" tIns="0" bIns="0">
+            <a:spAutoFit/>
+          </a:bodyPr>
+          <a:lstStyle/>
+          <a:p>
+            <a:pPr algn="l">
+              <a:spcBef>
+                <a:spcPts val="0"/>
+              </a:spcBef>
+              <a:spcAft>
+                <a:spcPts val="600"/>
+              </a:spcAft>
+            </a:pPr>
+            <a:r>
+              <a:rPr sz="3200" b="1" i="0">
+                <a:solidFill>
+                  <a:srgbClr val="1A1D21"/>
+                </a:solidFill>
+                <a:latin typeface="Segoe UI"/>
+              </a:rPr>
+              <a:t>A second interface, in Streamlit</a:t>
+            </a:r>
+          </a:p>
+        </p:txBody>
+      </p:sp>
+      <p:sp>
+        <p:nvSpPr>
+          <p:cNvPr id="3" name="TextBox 2"/>
+          <p:cNvSpPr txBox="1"/>
+          <p:nvPr/>
+        </p:nvSpPr>
+        <p:spPr>
+          <a:xfrm>
+            <a:off x="10070287" y="566928"/>
+            <a:ext cx="1463040" cy="365760"/>
+          </a:xfrm>
+          <a:prstGeom prst="rect">
+            <a:avLst/>
+          </a:prstGeom>
+          <a:noFill/>
+        </p:spPr>
+        <p:txBody>
+          <a:bodyPr wrap="square" anchor="t" lIns="0" rIns="0" tIns="0" bIns="0">
+            <a:spAutoFit/>
+          </a:bodyPr>
+          <a:lstStyle/>
+          <a:p>
+            <a:pPr algn="r">
+              <a:spcBef>
+                <a:spcPts val="0"/>
+              </a:spcBef>
+              <a:spcAft>
+                <a:spcPts val="600"/>
+              </a:spcAft>
+            </a:pPr>
+            <a:r>
+              <a:rPr sz="1300" b="0" i="0">
+                <a:solidFill>
+                  <a:srgbClr val="626B75"/>
+                </a:solidFill>
+                <a:latin typeface="Segoe UI"/>
+              </a:rPr>
+              <a:t>~20 sec</a:t>
+            </a:r>
+          </a:p>
+        </p:txBody>
+      </p:sp>
+      <p:sp>
+        <p:nvSpPr>
+          <p:cNvPr id="4" name="Rectangle 3"/>
+          <p:cNvSpPr/>
+          <p:nvPr/>
+        </p:nvSpPr>
+        <p:spPr>
+          <a:xfrm>
+            <a:off x="658368" y="1133856"/>
+            <a:ext cx="10874959" cy="19050"/>
+          </a:xfrm>
+          <a:prstGeom prst="rect">
+            <a:avLst/>
+          </a:prstGeom>
+          <a:solidFill>
+            <a:srgbClr val="DDE1E6"/>
+          </a:solidFill>
+          <a:ln>
+            <a:noFill/>
+          </a:ln>
+          <a:effectLst/>
+        </p:spPr>
+        <p:style>
+          <a:lnRef idx="1">
+            <a:schemeClr val="accent1"/>
+          </a:lnRef>
+          <a:fillRef idx="3">
+            <a:schemeClr val="accent1"/>
+          </a:fillRef>
+          <a:effectRef idx="2">
+            <a:schemeClr val="accent1"/>
+          </a:effectRef>
+          <a:fontRef idx="minor">
+            <a:schemeClr val="lt1"/>
+          </a:fontRef>
+        </p:style>
+        <p:txBody>
+          <a:bodyPr rtlCol="0" anchor="ctr"/>
+          <a:lstStyle/>
+          <a:p>
+            <a:pPr algn="ctr"/>
+          </a:p>
+        </p:txBody>
+      </p:sp>
+      <p:sp>
+        <p:nvSpPr>
+          <p:cNvPr id="5" name="TextBox 4"/>
+          <p:cNvSpPr txBox="1"/>
+          <p:nvPr/>
+        </p:nvSpPr>
+        <p:spPr>
+          <a:xfrm>
+            <a:off x="658368" y="1371600"/>
+            <a:ext cx="10874959" cy="411480"/>
+          </a:xfrm>
+          <a:prstGeom prst="rect">
+            <a:avLst/>
+          </a:prstGeom>
+          <a:noFill/>
+        </p:spPr>
+        <p:txBody>
+          <a:bodyPr wrap="square" anchor="t" lIns="0" rIns="0" tIns="0" bIns="0">
+            <a:spAutoFit/>
+          </a:bodyPr>
+          <a:lstStyle/>
+          <a:p>
+            <a:pPr algn="l">
+              <a:spcBef>
+                <a:spcPts val="0"/>
+              </a:spcBef>
+              <a:spcAft>
+                <a:spcPts val="600"/>
+              </a:spcAft>
+            </a:pPr>
+            <a:r>
+              <a:rPr sz="1800" b="1" i="0">
+                <a:solidFill>
+                  <a:srgbClr val="1A1D21"/>
+                </a:solidFill>
+                <a:latin typeface="Segoe UI"/>
+              </a:rPr>
+              <a:t>Same pipeline, a different front end — the annotation logic is a library, not part of the UI.</a:t>
+            </a:r>
+          </a:p>
+        </p:txBody>
+      </p:sp>
+      <p:sp>
+        <p:nvSpPr>
+          <p:cNvPr id="6" name="Rounded Rectangle 5"/>
+          <p:cNvSpPr/>
+          <p:nvPr/>
+        </p:nvSpPr>
+        <p:spPr>
+          <a:xfrm>
+            <a:off x="658368" y="1920240"/>
+            <a:ext cx="6812280" cy="3703320"/>
+          </a:xfrm>
+          <a:prstGeom prst="roundRect">
+            <a:avLst>
+              <a:gd name="adj" fmla="val 3000"/>
+            </a:avLst>
+          </a:prstGeom>
+          <a:solidFill>
+            <a:srgbClr val="F4F6F8"/>
+          </a:solidFill>
+          <a:ln w="12700">
+            <a:solidFill>
+              <a:srgbClr val="626B75"/>
+            </a:solidFill>
+            <a:prstDash val="dash"/>
+          </a:ln>
+          <a:effectLst/>
+        </p:spPr>
+        <p:style>
+          <a:lnRef idx="1">
+            <a:schemeClr val="accent1"/>
+          </a:lnRef>
+          <a:fillRef idx="3">
+            <a:schemeClr val="accent1"/>
+          </a:fillRef>
+          <a:effectRef idx="2">
+            <a:schemeClr val="accent1"/>
+          </a:effectRef>
+          <a:fontRef idx="minor">
+            <a:schemeClr val="lt1"/>
+          </a:fontRef>
+        </p:style>
+        <p:txBody>
+          <a:bodyPr rtlCol="0" anchor="ctr"/>
+          <a:lstStyle/>
+          <a:p>
+            <a:pPr algn="ctr"/>
+          </a:p>
+        </p:txBody>
+      </p:sp>
+      <p:sp>
+        <p:nvSpPr>
+          <p:cNvPr id="7" name="TextBox 6"/>
+          <p:cNvSpPr txBox="1"/>
+          <p:nvPr/>
+        </p:nvSpPr>
+        <p:spPr>
+          <a:xfrm>
+            <a:off x="841248" y="3461004"/>
+            <a:ext cx="6446520" cy="640080"/>
+          </a:xfrm>
+          <a:prstGeom prst="rect">
+            <a:avLst/>
+          </a:prstGeom>
+          <a:noFill/>
+        </p:spPr>
+        <p:txBody>
+          <a:bodyPr wrap="square" anchor="ctr" lIns="0" rIns="0" tIns="0" bIns="0">
+            <a:spAutoFit/>
+          </a:bodyPr>
+          <a:lstStyle/>
+          <a:p>
+            <a:pPr algn="ctr">
+              <a:spcBef>
+                <a:spcPts val="0"/>
+              </a:spcBef>
+              <a:spcAft>
+                <a:spcPts val="300"/>
+              </a:spcAft>
+            </a:pPr>
+            <a:r>
+              <a:rPr sz="1400" b="1" i="0">
+                <a:solidFill>
+                  <a:srgbClr val="626B75"/>
+                </a:solidFill>
+                <a:latin typeface="Segoe UI"/>
+              </a:rPr>
+              <a:t>screenshot goes here</a:t>
+            </a:r>
+          </a:p>
+          <a:p>
+            <a:pPr algn="ctr">
+              <a:spcBef>
+                <a:spcPts val="0"/>
+              </a:spcBef>
+              <a:spcAft>
+                <a:spcPts val="600"/>
+              </a:spcAft>
+            </a:pPr>
+            <a:r>
+              <a:rPr sz="1150" b="0" i="0">
+                <a:solidFill>
+                  <a:srgbClr val="626B75"/>
+                </a:solidFill>
+                <a:latin typeface="Segoe UI"/>
+              </a:rPr>
+              <a:t>deck-assets/streamlit-main.png  —  then re-run make_deck.py</a:t>
+            </a:r>
+          </a:p>
+        </p:txBody>
+      </p:sp>
+      <p:sp>
+        <p:nvSpPr>
+          <p:cNvPr id="8" name="TextBox 7"/>
+          <p:cNvSpPr txBox="1"/>
+          <p:nvPr/>
+        </p:nvSpPr>
+        <p:spPr>
+          <a:xfrm>
+            <a:off x="7726679" y="1920240"/>
+            <a:ext cx="3794760" cy="3657600"/>
+          </a:xfrm>
+          <a:prstGeom prst="rect">
+            <a:avLst/>
+          </a:prstGeom>
+          <a:noFill/>
+        </p:spPr>
+        <p:txBody>
+          <a:bodyPr wrap="square" anchor="t" lIns="0" rIns="0" tIns="0" bIns="0">
+            <a:spAutoFit/>
+          </a:bodyPr>
+          <a:lstStyle/>
+          <a:p>
+            <a:pPr algn="l">
+              <a:spcBef>
+                <a:spcPts val="0"/>
+              </a:spcBef>
+              <a:spcAft>
+                <a:spcPts val="700"/>
+              </a:spcAft>
+            </a:pPr>
+            <a:r>
+              <a:rPr sz="1600" b="1" i="0">
+                <a:solidFill>
+                  <a:srgbClr val="626B75"/>
+                </a:solidFill>
+                <a:latin typeface="Segoe UI"/>
+              </a:rPr>
+              <a:t>Why two</a:t>
+            </a:r>
+          </a:p>
+          <a:p>
+            <a:pPr algn="l">
+              <a:spcBef>
+                <a:spcPts val="0"/>
+              </a:spcBef>
+              <a:spcAft>
+                <a:spcPts val="200"/>
+              </a:spcAft>
+            </a:pPr>
+            <a:r>
+              <a:rPr sz="1400" b="0" i="0">
+                <a:solidFill>
+                  <a:srgbClr val="1A1D21"/>
+                </a:solidFill>
+                <a:latin typeface="Segoe UI"/>
+              </a:rPr>
+              <a:t>•  hpo_vocab.py and annotate.py hold the vocabulary, the search and the three-stage pipeline.</a:t>
+            </a:r>
+          </a:p>
+          <a:p>
+            <a:pPr algn="l">
+              <a:spcBef>
+                <a:spcPts val="0"/>
+              </a:spcBef>
+              <a:spcAft>
+                <a:spcPts val="200"/>
+              </a:spcAft>
+            </a:pPr>
+            <a:r>
+              <a:rPr sz="1350" b="0" i="0">
+                <a:solidFill>
+                  <a:srgbClr val="626B75"/>
+                </a:solidFill>
+                <a:latin typeface="Segoe UI"/>
+              </a:rPr>
+              <a:t>    Neither imports anything about a UI, so a second front end reuses them unchanged — and inherits the same guarantee.</a:t>
+            </a:r>
+          </a:p>
+          <a:p>
+            <a:pPr algn="l">
+              <a:spcBef>
+                <a:spcPts val="900"/>
+              </a:spcBef>
+              <a:spcAft>
+                <a:spcPts val="200"/>
+              </a:spcAft>
+            </a:pPr>
+            <a:r>
+              <a:rPr sz="1400" b="0" i="0">
+                <a:solidFill>
+                  <a:srgbClr val="1A1D21"/>
+                </a:solidFill>
+                <a:latin typeface="Segoe UI"/>
+              </a:rPr>
+              <a:t>•  The stdlib server has zero dependencies beyond anthropic.</a:t>
+            </a:r>
+          </a:p>
+          <a:p>
+            <a:pPr algn="l">
+              <a:spcBef>
+                <a:spcPts val="0"/>
+              </a:spcBef>
+              <a:spcAft>
+                <a:spcPts val="200"/>
+              </a:spcAft>
+            </a:pPr>
+            <a:r>
+              <a:rPr sz="1350" b="0" i="0">
+                <a:solidFill>
+                  <a:srgbClr val="626B75"/>
+                </a:solidFill>
+                <a:latin typeface="Segoe UI"/>
+              </a:rPr>
+              <a:t>    Runs anywhere Python does, no install step for a reviewer.</a:t>
+            </a:r>
+          </a:p>
+          <a:p>
+            <a:pPr algn="l">
+              <a:spcBef>
+                <a:spcPts val="900"/>
+              </a:spcBef>
+              <a:spcAft>
+                <a:spcPts val="200"/>
+              </a:spcAft>
+            </a:pPr>
+            <a:r>
+              <a:rPr sz="1400" b="0" i="0">
+                <a:solidFill>
+                  <a:srgbClr val="1A1D21"/>
+                </a:solidFill>
+                <a:latin typeface="Segoe UI"/>
+              </a:rPr>
+              <a:t>•  [TODO: what the Streamlit version does better — say it in one line]</a:t>
+            </a:r>
+          </a:p>
+          <a:p>
+            <a:pPr algn="l">
+              <a:spcBef>
+                <a:spcPts val="0"/>
+              </a:spcBef>
+              <a:spcAft>
+                <a:spcPts val="200"/>
+              </a:spcAft>
+            </a:pPr>
+            <a:r>
+              <a:rPr sz="1350" b="0" i="0">
+                <a:solidFill>
+                  <a:srgbClr val="626B75"/>
+                </a:solidFill>
+                <a:latin typeface="Segoe UI"/>
+              </a:rPr>
+              <a:t>    Replace this with the honest reason it exists.</a:t>
+            </a:r>
+          </a:p>
+        </p:txBody>
+      </p:sp>
+    </p:spTree>
+  </p:cSld>
+  <p:clrMapOvr>
+    <a:masterClrMapping/>
+  </p:clrMapOvr>
+</p:sld>
+</file>
+
+<file path=ppt/slides/slide6.xml><?xml version="1.0" encoding="utf-8"?>
 <p:sld xmlns:a="http://schemas.openxmlformats.org/drawingml/2006/main" xmlns:p="http://schemas.openxmlformats.org/presentationml/2006/main" xmlns:r="http://schemas.openxmlformats.org/officeDocument/2006/relationships">
   <p:cSld>
     <p:spTree>

</xml_diff>